<commit_message>
Module 5 work: fixed slide deck
</commit_message>
<xml_diff>
--- a/05-super-speed/quiet-responders-deck.pptx
+++ b/05-super-speed/quiet-responders-deck.pptx
@@ -106,7 +106,7 @@
           </a:xfrm>
           <a:prstGeom prst="roundRect">
             <a:avLst>
-              <a:gd name="adj" fmla="val 6000"/>
+              <a:gd name="adj" fmla="val 0"/>
             </a:avLst>
           </a:prstGeom>
           <a:solidFill>
@@ -121,6 +121,9 @@
             <a:normAutofit/>
           </a:bodyPr>
           <a:lstStyle/>
+          <a:p>
+            <a:endParaRPr lang="en-US"/>
+          </a:p>
         </p:txBody>
       </p:sp>
       <p:sp>
@@ -660,7 +663,7 @@
         <p:spPr>
           <a:xfrm>
             <a:off x="508000" y="1270000"/>
-            <a:ext cx="3556000" cy="4826000"/>
+            <a:ext cx="3556000" cy="0"/>
           </a:xfrm>
           <a:prstGeom prst="roundRect">
             <a:avLst>
@@ -746,7 +749,7 @@
         <p:spPr>
           <a:xfrm>
             <a:off x="4318000" y="1270000"/>
-            <a:ext cx="3556000" cy="4826000"/>
+            <a:ext cx="3556000" cy="0"/>
           </a:xfrm>
           <a:prstGeom prst="roundRect">
             <a:avLst>
@@ -832,7 +835,7 @@
         <p:spPr>
           <a:xfrm>
             <a:off x="8128000" y="1270000"/>
-            <a:ext cx="3556000" cy="4826000"/>
+            <a:ext cx="3556000" cy="0"/>
           </a:xfrm>
           <a:prstGeom prst="roundRect">
             <a:avLst>

</xml_diff>

<commit_message>
Module 5 work: deck with retry slide
</commit_message>
<xml_diff>
--- a/05-super-speed/quiet-responders-deck.pptx
+++ b/05-super-speed/quiet-responders-deck.pptx
@@ -11,6 +11,7 @@
     <p:sldId id="259" r:id="rId5"/>
     <p:sldId id="260" r:id="rId6"/>
     <p:sldId id="261" r:id="rId7"/>
+    <p:sldId id="262" r:id="rId8"/>
   </p:sldIdLst>
   <p:sldSz cx="12192000" cy="6858000"/>
   <p:notesSz cx="6858000" cy="9144000"/>
@@ -871,7 +872,7 @@
                 <a:latin typeface="Arial"/>
                 <a:cs typeface="Arial"/>
               </a:rPr>
-              <a:t>Any responder whose ping is missed</a:t>
+              <a:t>Any responder: retry on a missed ping</a:t>
             </a:r>
           </a:p>
           <a:p>
@@ -907,7 +908,7 @@
                 <a:latin typeface="Arial"/>
                 <a:cs typeface="Arial"/>
               </a:rPr>
-              <a:t>Now: one nudge to the same responder inside the same 90s wait. Answer the nudge and it counts as taken. Only a ping still unanswered after the nudge is a miss.</a:t>
+              <a:t>Now: one retry to the same responder inside the same 90s wait. Answer the retry and it counts as taken. Only a ping still unanswered after the retry is a miss.</a:t>
             </a:r>
           </a:p>
         </p:txBody>
@@ -978,35 +979,11 @@
                 <a:latin typeface="Arial"/>
                 <a:cs typeface="Arial"/>
               </a:rPr>
-              <a:t>The workflow</a:t>
+              <a:t>New: retry when a ping is missed</a:t>
             </a:r>
           </a:p>
         </p:txBody>
       </p:sp>
-      <p:pic>
-        <p:nvPicPr>
-          <p:cNvPr id="50" name="Workflow diagram" descr="Workflow for bringing quiet responders back"/>
-          <p:cNvPicPr>
-            <a:picLocks noChangeAspect="1"/>
-          </p:cNvPicPr>
-          <p:nvPr/>
-        </p:nvPicPr>
-        <p:blipFill>
-          <a:blip r:embed="rId2"/>
-          <a:stretch>
-            <a:fillRect/>
-          </a:stretch>
-        </p:blipFill>
-        <p:spPr>
-          <a:xfrm>
-            <a:off x="3111500" y="1066800"/>
-            <a:ext cx="5969000" cy="5306060"/>
-          </a:xfrm>
-          <a:prstGeom prst="rect">
-            <a:avLst/>
-          </a:prstGeom>
-        </p:spPr>
-      </p:pic>
       <p:sp>
         <p:nvSpPr>
           <p:cNvPr id="3" name="Shape 3"/>
@@ -1015,15 +992,183 @@
         </p:nvSpPr>
         <p:spPr>
           <a:xfrm>
-            <a:off x="508000" y="6477000"/>
-            <a:ext cx="11176000" cy="304800"/>
+            <a:off x="508000" y="1270000"/>
+            <a:ext cx="5461000" cy="4953000"/>
           </a:xfrm>
           <a:prstGeom prst="roundRect">
             <a:avLst>
               <a:gd name="adj" fmla="val 6000"/>
             </a:avLst>
           </a:prstGeom>
-          <a:noFill/>
+          <a:solidFill>
+            <a:srgbClr val="F3E8FF"/>
+          </a:solidFill>
+          <a:ln w="19050">
+            <a:solidFill>
+              <a:srgbClr val="7C3AED"/>
+            </a:solidFill>
+          </a:ln>
+        </p:spPr>
+        <p:txBody>
+          <a:bodyPr wrap="square" lIns="137160" tIns="91440" rIns="137160" bIns="91440" anchor="t">
+            <a:normAutofit/>
+          </a:bodyPr>
+          <a:lstStyle/>
+          <a:p>
+            <a:pPr>
+              <a:spcBef>
+                <a:spcPts val="600"/>
+              </a:spcBef>
+              <a:buNone/>
+            </a:pPr>
+            <a:r>
+              <a:rPr lang="en-US" sz="1600" b="1" dirty="0">
+                <a:solidFill>
+                  <a:srgbClr val="1F3864"/>
+                </a:solidFill>
+                <a:latin typeface="Arial"/>
+                <a:cs typeface="Arial"/>
+              </a:rPr>
+              <a:t>How the retry works</a:t>
+            </a:r>
+          </a:p>
+          <a:p>
+            <a:pPr marL="285750" indent="-285750">
+              <a:spcBef>
+                <a:spcPts val="900"/>
+              </a:spcBef>
+              <a:buFont typeface="Arial"/>
+              <a:buChar char="•"/>
+            </a:pPr>
+            <a:r>
+              <a:rPr lang="en-US" sz="1400" b="1" dirty="0">
+                <a:solidFill>
+                  <a:srgbClr val="1F2937"/>
+                </a:solidFill>
+                <a:latin typeface="Arial"/>
+                <a:cs typeface="Arial"/>
+              </a:rPr>
+              <a:t>1.</a:t>
+            </a:r>
+            <a:r>
+              <a:rPr lang="en-US" sz="1400" dirty="0">
+                <a:solidFill>
+                  <a:srgbClr val="1F2937"/>
+                </a:solidFill>
+                <a:latin typeface="Arial"/>
+                <a:cs typeface="Arial"/>
+              </a:rPr>
+              <a:t> The ping goes to the top responder with a 90 second wait.</a:t>
+            </a:r>
+          </a:p>
+          <a:p>
+            <a:pPr marL="285750" indent="-285750">
+              <a:spcBef>
+                <a:spcPts val="900"/>
+              </a:spcBef>
+              <a:buFont typeface="Arial"/>
+              <a:buChar char="•"/>
+            </a:pPr>
+            <a:r>
+              <a:rPr lang="en-US" sz="1400" b="1" dirty="0">
+                <a:solidFill>
+                  <a:srgbClr val="1F2937"/>
+                </a:solidFill>
+                <a:latin typeface="Arial"/>
+                <a:cs typeface="Arial"/>
+              </a:rPr>
+              <a:t>2.</a:t>
+            </a:r>
+            <a:r>
+              <a:rPr lang="en-US" sz="1400" dirty="0">
+                <a:solidFill>
+                  <a:srgbClr val="1F2937"/>
+                </a:solidFill>
+                <a:latin typeface="Arial"/>
+                <a:cs typeface="Arial"/>
+              </a:rPr>
+              <a:t> Halfway through, with no answer, the same responder gets one retry: a second alert on their phone.</a:t>
+            </a:r>
+          </a:p>
+          <a:p>
+            <a:pPr marL="285750" indent="-285750">
+              <a:spcBef>
+                <a:spcPts val="900"/>
+              </a:spcBef>
+              <a:buFont typeface="Arial"/>
+              <a:buChar char="•"/>
+            </a:pPr>
+            <a:r>
+              <a:rPr lang="en-US" sz="1400" b="1" dirty="0">
+                <a:solidFill>
+                  <a:srgbClr val="1F2937"/>
+                </a:solidFill>
+                <a:latin typeface="Arial"/>
+                <a:cs typeface="Arial"/>
+              </a:rPr>
+              <a:t>3.</a:t>
+            </a:r>
+            <a:r>
+              <a:rPr lang="en-US" sz="1400" dirty="0">
+                <a:solidFill>
+                  <a:srgbClr val="1F2937"/>
+                </a:solidFill>
+                <a:latin typeface="Arial"/>
+                <a:cs typeface="Arial"/>
+              </a:rPr>
+              <a:t> An answer to either alert counts as taken, with no penalty.</a:t>
+            </a:r>
+          </a:p>
+          <a:p>
+            <a:pPr marL="285750" indent="-285750">
+              <a:spcBef>
+                <a:spcPts val="900"/>
+              </a:spcBef>
+              <a:buFont typeface="Arial"/>
+              <a:buChar char="•"/>
+            </a:pPr>
+            <a:r>
+              <a:rPr lang="en-US" sz="1400" b="1" dirty="0">
+                <a:solidFill>
+                  <a:srgbClr val="1F2937"/>
+                </a:solidFill>
+                <a:latin typeface="Arial"/>
+                <a:cs typeface="Arial"/>
+              </a:rPr>
+              <a:t>4.</a:t>
+            </a:r>
+            <a:r>
+              <a:rPr lang="en-US" sz="1400" dirty="0">
+                <a:solidFill>
+                  <a:srgbClr val="1F2937"/>
+                </a:solidFill>
+                <a:latin typeface="Arial"/>
+                <a:cs typeface="Arial"/>
+              </a:rPr>
+              <a:t> Still silent at 90 seconds: recorded as missed, and the ping moves on.</a:t>
+            </a:r>
+          </a:p>
+        </p:txBody>
+      </p:sp>
+      <p:sp>
+        <p:nvSpPr>
+          <p:cNvPr id="4" name="Shape 4"/>
+          <p:cNvSpPr/>
+          <p:nvPr/>
+        </p:nvSpPr>
+        <p:spPr>
+          <a:xfrm>
+            <a:off x="6223000" y="1270000"/>
+            <a:ext cx="5461000" cy="4953000"/>
+          </a:xfrm>
+          <a:prstGeom prst="roundRect">
+            <a:avLst>
+              <a:gd name="adj" fmla="val 6000"/>
+            </a:avLst>
+          </a:prstGeom>
+          <a:solidFill>
+            <a:srgbClr val="F3F4F6"/>
+          </a:solidFill>
           <a:ln>
             <a:noFill/>
           </a:ln>
@@ -1041,14 +1186,129 @@
               <a:buNone/>
             </a:pPr>
             <a:r>
-              <a:rPr lang="en-US" sz="1100" dirty="0">
+              <a:rPr lang="en-US" sz="1600" b="1" dirty="0">
+                <a:solidFill>
+                  <a:srgbClr val="1F3864"/>
+                </a:solidFill>
+                <a:latin typeface="Arial"/>
+                <a:cs typeface="Arial"/>
+              </a:rPr>
+              <a:t>Why, and what we still need to decide</a:t>
+            </a:r>
+          </a:p>
+          <a:p>
+            <a:pPr marL="285750" indent="-285750">
+              <a:spcBef>
+                <a:spcPts val="900"/>
+              </a:spcBef>
+              <a:buFont typeface="Arial"/>
+              <a:buChar char="•"/>
+            </a:pPr>
+            <a:r>
+              <a:rPr lang="en-US" sz="1400" dirty="0">
+                <a:solidFill>
+                  <a:srgbClr val="1F2937"/>
+                </a:solidFill>
+                <a:latin typeface="Arial"/>
+                <a:cs typeface="Arial"/>
+              </a:rPr>
+              <a:t>A missed alert costs 0.12 of score straight away. The retry gives a missed or unseen alert a second chance before that happens.</a:t>
+            </a:r>
+          </a:p>
+          <a:p>
+            <a:pPr marL="285750" indent="-285750">
+              <a:spcBef>
+                <a:spcPts val="900"/>
+              </a:spcBef>
+              <a:buFont typeface="Arial"/>
+              <a:buChar char="•"/>
+            </a:pPr>
+            <a:r>
+              <a:rPr lang="en-US" sz="1400" b="1" dirty="0">
+                <a:solidFill>
+                  <a:srgbClr val="1F2937"/>
+                </a:solidFill>
+                <a:latin typeface="Arial"/>
+                <a:cs typeface="Arial"/>
+              </a:rPr>
+              <a:t>Retry inside the 90s window (proposed):</a:t>
+            </a:r>
+            <a:r>
+              <a:rPr lang="en-US" sz="1400" dirty="0">
+                <a:solidFill>
+                  <a:srgbClr val="1F2937"/>
+                </a:solidFill>
+                <a:latin typeface="Arial"/>
+                <a:cs typeface="Arial"/>
+              </a:rPr>
+              <a:t> five misses in a row take 450s.</a:t>
+            </a:r>
+          </a:p>
+          <a:p>
+            <a:pPr marL="285750" indent="-285750">
+              <a:spcBef>
+                <a:spcPts val="900"/>
+              </a:spcBef>
+              <a:buFont typeface="Arial"/>
+              <a:buChar char="•"/>
+            </a:pPr>
+            <a:r>
+              <a:rPr lang="en-US" sz="1400" b="1" dirty="0">
+                <a:solidFill>
+                  <a:srgbClr val="1F2937"/>
+                </a:solidFill>
+                <a:latin typeface="Arial"/>
+                <a:cs typeface="Arial"/>
+              </a:rPr>
+              <a:t>Second full window:</a:t>
+            </a:r>
+            <a:r>
+              <a:rPr lang="en-US" sz="1400" dirty="0">
+                <a:solidFill>
+                  <a:srgbClr val="1F2937"/>
+                </a:solidFill>
+                <a:latin typeface="Arial"/>
+                <a:cs typeface="Arial"/>
+              </a:rPr>
+              <a:t> up to 180s per responder; five misses take 900s.</a:t>
+            </a:r>
+          </a:p>
+          <a:p>
+            <a:pPr marL="285750" indent="-285750">
+              <a:spcBef>
+                <a:spcPts val="900"/>
+              </a:spcBef>
+              <a:buFont typeface="Arial"/>
+              <a:buChar char="•"/>
+            </a:pPr>
+            <a:r>
+              <a:rPr lang="en-US" sz="1300" dirty="0">
                 <a:solidFill>
                   <a:srgbClr val="595959"/>
                 </a:solidFill>
                 <a:latin typeface="Arial"/>
                 <a:cs typeface="Arial"/>
               </a:rPr>
-              <a:t>Purple dashed = new. Grey = today. N and the nudge timing are not set yet.</a:t>
+              <a:t>Limits: it only helps if the miss was an unseen alert, and we cannot yet tell a failed push from no answer. Of 135 missed pings, 26 ended with nobody left to ask.</a:t>
+            </a:r>
+          </a:p>
+          <a:p>
+            <a:pPr marL="285750" indent="-285750">
+              <a:spcBef>
+                <a:spcPts val="900"/>
+              </a:spcBef>
+              <a:buFont typeface="Arial"/>
+              <a:buChar char="•"/>
+            </a:pPr>
+            <a:r>
+              <a:rPr lang="en-US" sz="1300" dirty="0">
+                <a:solidFill>
+                  <a:srgbClr val="595959"/>
+                </a:solidFill>
+                <a:latin typeface="Arial"/>
+                <a:cs typeface="Arial"/>
+              </a:rPr>
+              <a:t>Ravi must agree what counts as a ping and a miss once a retry exists.</a:t>
             </a:r>
           </a:p>
         </p:txBody>
@@ -1119,6 +1379,147 @@
                 <a:latin typeface="Arial"/>
                 <a:cs typeface="Arial"/>
               </a:rPr>
+              <a:t>The workflow</a:t>
+            </a:r>
+          </a:p>
+        </p:txBody>
+      </p:sp>
+      <p:pic>
+        <p:nvPicPr>
+          <p:cNvPr id="50" name="Workflow diagram" descr="Workflow for bringing quiet responders back"/>
+          <p:cNvPicPr>
+            <a:picLocks noChangeAspect="1"/>
+          </p:cNvPicPr>
+          <p:nvPr/>
+        </p:nvPicPr>
+        <p:blipFill>
+          <a:blip r:embed="rId2"/>
+          <a:stretch>
+            <a:fillRect/>
+          </a:stretch>
+        </p:blipFill>
+        <p:spPr>
+          <a:xfrm>
+            <a:off x="3111500" y="1066800"/>
+            <a:ext cx="5969000" cy="5306060"/>
+          </a:xfrm>
+          <a:prstGeom prst="rect">
+            <a:avLst/>
+          </a:prstGeom>
+        </p:spPr>
+      </p:pic>
+      <p:sp>
+        <p:nvSpPr>
+          <p:cNvPr id="3" name="Shape 3"/>
+          <p:cNvSpPr/>
+          <p:nvPr/>
+        </p:nvSpPr>
+        <p:spPr>
+          <a:xfrm>
+            <a:off x="508000" y="6477000"/>
+            <a:ext cx="11176000" cy="304800"/>
+          </a:xfrm>
+          <a:prstGeom prst="roundRect">
+            <a:avLst>
+              <a:gd name="adj" fmla="val 6000"/>
+            </a:avLst>
+          </a:prstGeom>
+          <a:noFill/>
+          <a:ln>
+            <a:noFill/>
+          </a:ln>
+        </p:spPr>
+        <p:txBody>
+          <a:bodyPr wrap="square" lIns="137160" tIns="91440" rIns="137160" bIns="91440" anchor="t">
+            <a:normAutofit/>
+          </a:bodyPr>
+          <a:lstStyle/>
+          <a:p>
+            <a:pPr>
+              <a:spcBef>
+                <a:spcPts val="600"/>
+              </a:spcBef>
+              <a:buNone/>
+            </a:pPr>
+            <a:r>
+              <a:rPr lang="en-US" sz="1100" dirty="0">
+                <a:solidFill>
+                  <a:srgbClr val="595959"/>
+                </a:solidFill>
+                <a:latin typeface="Arial"/>
+                <a:cs typeface="Arial"/>
+              </a:rPr>
+              <a:t>Purple dashed = new. Grey = today. N and the retry timing are not set yet.</a:t>
+            </a:r>
+          </a:p>
+        </p:txBody>
+      </p:sp>
+    </p:spTree>
+  </p:cSld>
+  <p:clrMapOvr>
+    <a:masterClrMapping/>
+  </p:clrMapOvr>
+</p:sld>
+</file>
+
+<file path=ppt/slides/slide6.xml><?xml version="1.0" encoding="utf-8"?>
+<p:sld xmlns:a="http://schemas.openxmlformats.org/drawingml/2006/main" xmlns:r="http://schemas.openxmlformats.org/officeDocument/2006/relationships" xmlns:p="http://schemas.openxmlformats.org/presentationml/2006/main">
+  <p:cSld>
+    <p:spTree>
+      <p:nvGrpSpPr>
+        <p:cNvPr id="1" name=""/>
+        <p:cNvGrpSpPr/>
+        <p:nvPr/>
+      </p:nvGrpSpPr>
+      <p:grpSpPr>
+        <a:xfrm>
+          <a:off x="0" y="0"/>
+          <a:ext cx="0" cy="0"/>
+          <a:chOff x="0" y="0"/>
+          <a:chExt cx="0" cy="0"/>
+        </a:xfrm>
+      </p:grpSpPr>
+      <p:sp>
+        <p:nvSpPr>
+          <p:cNvPr id="2" name="Shape 2"/>
+          <p:cNvSpPr/>
+          <p:nvPr/>
+        </p:nvSpPr>
+        <p:spPr>
+          <a:xfrm>
+            <a:off x="508000" y="304800"/>
+            <a:ext cx="11176000" cy="711200"/>
+          </a:xfrm>
+          <a:prstGeom prst="roundRect">
+            <a:avLst>
+              <a:gd name="adj" fmla="val 6000"/>
+            </a:avLst>
+          </a:prstGeom>
+          <a:noFill/>
+          <a:ln>
+            <a:noFill/>
+          </a:ln>
+        </p:spPr>
+        <p:txBody>
+          <a:bodyPr wrap="square" lIns="137160" tIns="91440" rIns="137160" bIns="91440" anchor="ctr">
+            <a:normAutofit/>
+          </a:bodyPr>
+          <a:lstStyle/>
+          <a:p>
+            <a:pPr>
+              <a:spcBef>
+                <a:spcPts val="600"/>
+              </a:spcBef>
+              <a:buNone/>
+            </a:pPr>
+            <a:r>
+              <a:rPr lang="en-US" sz="2800" b="1" dirty="0">
+                <a:solidFill>
+                  <a:srgbClr val="1F3864"/>
+                </a:solidFill>
+                <a:latin typeface="Arial"/>
+                <a:cs typeface="Arial"/>
+              </a:rPr>
               <a:t>What it deliberately does not do</a:t>
             </a:r>
           </a:p>
@@ -1223,7 +1624,7 @@
                 <a:latin typeface="Arial"/>
                 <a:cs typeface="Arial"/>
               </a:rPr>
-              <a:t>The retry is one nudge: no repeated pings, and no retry after a turn-down.</a:t>
+              <a:t>The retry is a single second alert: no repeated pings, and no retry after a turn-down.</a:t>
             </a:r>
           </a:p>
           <a:p>
@@ -1274,7 +1675,7 @@
 </p:sld>
 </file>
 
-<file path=ppt/slides/slide6.xml><?xml version="1.0" encoding="utf-8"?>
+<file path=ppt/slides/slide7.xml><?xml version="1.0" encoding="utf-8"?>
 <p:sld xmlns:a="http://schemas.openxmlformats.org/drawingml/2006/main" xmlns:r="http://schemas.openxmlformats.org/officeDocument/2006/relationships" xmlns:p="http://schemas.openxmlformats.org/presentationml/2006/main">
   <p:cSld>
     <p:spTree>

</xml_diff>